<commit_message>
i18n(da): one prompt for each placeholder in the new presentation
The Danish new.pptx gave the title, subtitle and body placeholders of
the slide master and its layouts the same prompt, "Klik for at redigere
i master". Each now has its own, as established Danish terminology
words them: "Klik for at redigere titeltypografien i masteren",
"... undertiteltypografien ..." and "... teksttypografierne ...",
in 26 places.

The built-in cell style in the Danish new.xlsx was named "常规",
which is Chinese for Normal. It is Normal again.

Assisted-by: Claude:claude-opus-5-5
Signed-off-by: bargib <258776918+bargib@users.noreply.github.com>
</commit_message>
<xml_diff>
--- a/new/da-DK/new.pptx
+++ b/new/da-DK/new.pptx
@@ -155,7 +155,7 @@
           <a:p>
             <a:r>
               <a:rPr lang="da-DK"/>
-              <a:t>Klik for at redigere i master</a:t>
+              <a:t>Klik for at redigere titeltypografien i masteren</a:t>
             </a:r>
           </a:p>
         </p:txBody>
@@ -219,7 +219,7 @@
           <a:p>
             <a:r>
               <a:rPr lang="da-DK"/>
-              <a:t>Klik for at redigere i master</a:t>
+              <a:t>Klik for at redigere undertiteltypografien i masteren</a:t>
             </a:r>
           </a:p>
         </p:txBody>
@@ -336,7 +336,7 @@
           <a:p>
             <a:r>
               <a:rPr lang="da-DK"/>
-              <a:t>Klik for at redigere i master</a:t>
+              <a:t>Klik for at redigere titeltypografien i masteren</a:t>
             </a:r>
           </a:p>
         </p:txBody>
@@ -359,7 +359,7 @@
             <a:pPr lvl="0"/>
             <a:r>
               <a:rPr lang="da-DK"/>
-              <a:t>Klik for at redigere i master</a:t>
+              <a:t>Klik for at redigere teksttypografierne i masteren</a:t>
             </a:r>
           </a:p>
           <a:p>
@@ -509,7 +509,7 @@
           <a:p>
             <a:r>
               <a:rPr lang="da-DK"/>
-              <a:t>Klik for at redigere i master</a:t>
+              <a:t>Klik for at redigere titeltypografien i masteren</a:t>
             </a:r>
           </a:p>
         </p:txBody>
@@ -537,7 +537,7 @@
             <a:pPr lvl="0"/>
             <a:r>
               <a:rPr lang="da-DK"/>
-              <a:t>Klik for at redigere i master</a:t>
+              <a:t>Klik for at redigere teksttypografierne i masteren</a:t>
             </a:r>
           </a:p>
           <a:p>
@@ -682,7 +682,7 @@
           <a:p>
             <a:r>
               <a:rPr lang="da-DK"/>
-              <a:t>Klik for at redigere i master</a:t>
+              <a:t>Klik for at redigere titeltypografien i masteren</a:t>
             </a:r>
           </a:p>
         </p:txBody>
@@ -705,7 +705,7 @@
             <a:pPr lvl="0"/>
             <a:r>
               <a:rPr lang="da-DK"/>
-              <a:t>Klik for at redigere i master</a:t>
+              <a:t>Klik for at redigere teksttypografierne i masteren</a:t>
             </a:r>
           </a:p>
           <a:p>
@@ -859,7 +859,7 @@
           <a:p>
             <a:r>
               <a:rPr lang="da-DK"/>
-              <a:t>Klik for at redigere i master</a:t>
+              <a:t>Klik for at redigere titeltypografien i masteren</a:t>
             </a:r>
           </a:p>
         </p:txBody>
@@ -978,7 +978,7 @@
             <a:pPr lvl="0"/>
             <a:r>
               <a:rPr lang="da-DK"/>
-              <a:t>Klik for at redigere i master</a:t>
+              <a:t>Klik for at redigere teksttypografierne i masteren</a:t>
             </a:r>
           </a:p>
         </p:txBody>
@@ -1095,7 +1095,7 @@
           <a:p>
             <a:r>
               <a:rPr lang="da-DK"/>
-              <a:t>Klik for at redigere i master</a:t>
+              <a:t>Klik for at redigere titeltypografien i masteren</a:t>
             </a:r>
           </a:p>
         </p:txBody>
@@ -1123,7 +1123,7 @@
             <a:pPr lvl="0"/>
             <a:r>
               <a:rPr lang="da-DK"/>
-              <a:t>Klik for at redigere i master</a:t>
+              <a:t>Klik for at redigere teksttypografierne i masteren</a:t>
             </a:r>
           </a:p>
           <a:p>
@@ -1179,7 +1179,7 @@
             <a:pPr lvl="0"/>
             <a:r>
               <a:rPr lang="da-DK"/>
-              <a:t>Klik for at redigere i master</a:t>
+              <a:t>Klik for at redigere teksttypografierne i masteren</a:t>
             </a:r>
           </a:p>
           <a:p>
@@ -1329,7 +1329,7 @@
           <a:p>
             <a:r>
               <a:rPr lang="da-DK"/>
-              <a:t>Klik for at redigere i master</a:t>
+              <a:t>Klik for at redigere titeltypografien i masteren</a:t>
             </a:r>
           </a:p>
         </p:txBody>
@@ -1394,7 +1394,7 @@
             <a:pPr lvl="0"/>
             <a:r>
               <a:rPr lang="da-DK"/>
-              <a:t>Klik for at redigere i master</a:t>
+              <a:t>Klik for at redigere teksttypografierne i masteren</a:t>
             </a:r>
           </a:p>
         </p:txBody>
@@ -1422,7 +1422,7 @@
             <a:pPr lvl="0"/>
             <a:r>
               <a:rPr lang="da-DK"/>
-              <a:t>Klik for at redigere i master</a:t>
+              <a:t>Klik for at redigere teksttypografierne i masteren</a:t>
             </a:r>
           </a:p>
           <a:p>
@@ -1515,7 +1515,7 @@
             <a:pPr lvl="0"/>
             <a:r>
               <a:rPr lang="da-DK"/>
-              <a:t>Klik for at redigere i master</a:t>
+              <a:t>Klik for at redigere teksttypografierne i masteren</a:t>
             </a:r>
           </a:p>
         </p:txBody>
@@ -1543,7 +1543,7 @@
             <a:pPr lvl="0"/>
             <a:r>
               <a:rPr lang="da-DK"/>
-              <a:t>Klik for at redigere i master</a:t>
+              <a:t>Klik for at redigere teksttypografierne i masteren</a:t>
             </a:r>
           </a:p>
           <a:p>
@@ -1688,7 +1688,7 @@
           <a:p>
             <a:r>
               <a:rPr lang="da-DK"/>
-              <a:t>Klik for at redigere i master</a:t>
+              <a:t>Klik for at redigere titeltypografien i masteren</a:t>
             </a:r>
           </a:p>
         </p:txBody>
@@ -1909,7 +1909,7 @@
           <a:p>
             <a:r>
               <a:rPr lang="da-DK"/>
-              <a:t>Klik for at redigere i master</a:t>
+              <a:t>Klik for at redigere titeltypografien i masteren</a:t>
             </a:r>
           </a:p>
         </p:txBody>
@@ -1965,7 +1965,7 @@
             <a:pPr lvl="0"/>
             <a:r>
               <a:rPr lang="da-DK"/>
-              <a:t>Klik for at redigere i master</a:t>
+              <a:t>Klik for at redigere teksttypografierne i masteren</a:t>
             </a:r>
           </a:p>
           <a:p>
@@ -2058,7 +2058,7 @@
             <a:pPr lvl="0"/>
             <a:r>
               <a:rPr lang="da-DK"/>
-              <a:t>Klik for at redigere i master</a:t>
+              <a:t>Klik for at redigere teksttypografierne i masteren</a:t>
             </a:r>
           </a:p>
         </p:txBody>
@@ -2184,7 +2184,7 @@
           <a:p>
             <a:r>
               <a:rPr lang="da-DK"/>
-              <a:t>Klik for at redigere i master</a:t>
+              <a:t>Klik for at redigere titeltypografien i masteren</a:t>
             </a:r>
           </a:p>
         </p:txBody>
@@ -2310,7 +2310,7 @@
             <a:pPr lvl="0"/>
             <a:r>
               <a:rPr lang="da-DK"/>
-              <a:t>Klik for at redigere i master</a:t>
+              <a:t>Klik for at redigere teksttypografierne i masteren</a:t>
             </a:r>
           </a:p>
         </p:txBody>
@@ -2442,7 +2442,7 @@
           <a:p>
             <a:r>
               <a:rPr lang="da-DK"/>
-              <a:t>Klik for at redigere i master</a:t>
+              <a:t>Klik for at redigere titeltypografien i masteren</a:t>
             </a:r>
           </a:p>
         </p:txBody>
@@ -2475,7 +2475,7 @@
             <a:pPr lvl="0"/>
             <a:r>
               <a:rPr lang="da-DK"/>
-              <a:t>Klik for at redigere i master</a:t>
+              <a:t>Klik for at redigere teksttypografierne i masteren</a:t>
             </a:r>
           </a:p>
           <a:p>

</xml_diff>